<commit_message>
Add HR research & recruiting status deck; update visit deck for 5 companies
Co-Authored-By: Claude Opus 5.5 <noreply@anthropic.com>
Claude-Session: https://claude.ai/code/session_017xwq7G19z64Ho1gF63vaho
</commit_message>
<xml_diff>
--- a/シリコンバレー企業見学_2026年10月.pptx
+++ b/シリコンバレー企業見学_2026年10月.pptx
@@ -114,26 +114,26 @@
   <p:extLst>
     <p:ext uri="{521415D9-36F7-43E2-AB2F-B90AF26B5E84}">
       <p14:sectionLst xmlns:p14="http://schemas.microsoft.com/office/powerpoint/2010/main">
-        <p14:section name="イントロ" id="{49791d2c-6166-09ca-485d-3adfd4c623f8}">
+        <p14:section name="イントロ" id="{e2b7ca73-d73e-3e07-a372-906ac5a9f0a5}">
           <p14:sldIdLst>
             <p14:sldId id="256"/>
           </p14:sldIdLst>
         </p14:section>
-        <p14:section name="Why" id="{bb60f9a9-2ad9-26d6-bfe0-3a0c35b207a8}">
+        <p14:section name="Why" id="{6f546826-b9c3-f75b-40a5-02d7d66c3a0c}">
           <p14:sldIdLst>
             <p14:sldId id="257"/>
             <p14:sldId id="258"/>
             <p14:sldId id="259"/>
           </p14:sldIdLst>
         </p14:section>
-        <p14:section name="アクション" id="{fbd062da-64c9-dca6-7ed0-2775c6b0ea3e}">
+        <p14:section name="アクション" id="{bdceb541-3630-147f-d4b0-8d693676ee2d}">
           <p14:sldIdLst>
             <p14:sldId id="260"/>
             <p14:sldId id="261"/>
             <p14:sldId id="262"/>
           </p14:sldIdLst>
         </p14:section>
-        <p14:section name="まとめ" id="{4349f1a6-159c-09d6-71c8-30c4a46a8c03}">
+        <p14:section name="まとめ" id="{7116375d-8cf6-c69e-b50e-8dd6fecc3ee4}">
           <p14:sldIdLst>
             <p14:sldId id="263"/>
           </p14:sldIdLst>
@@ -2240,7 +2240,7 @@
                   <a:schemeClr val="accent5"/>
                 </a:solidFill>
               </a:rPr>
-              <a:t>2026年10月　｜　Google ・ Meta ・ Stanford ・ Tesla</a:t>
+              <a:t>2026年10月　｜　Tesla ・ Google ・ NASA ・ Meta ・ Stanford</a:t>
             </a:r>
             <a:endParaRPr lang="en-US" sz="1200" dirty="0"/>
           </a:p>
@@ -4111,7 +4111,7 @@
                   <a:schemeClr val="tx2"/>
                 </a:solidFill>
               </a:rPr>
-              <a:t>Google・Meta・Stanford・Teslaの人事の仕組みを現地で学ぶ</a:t>
+              <a:t>Tesla・Google・NASA・Meta・Stanfordの人事の仕組みを現地で学ぶ</a:t>
             </a:r>
             <a:endParaRPr lang="en-US" sz="1100" dirty="0"/>
           </a:p>
@@ -4839,7 +4839,7 @@
                   <a:schemeClr val="tx1"/>
                 </a:solidFill>
               </a:rPr>
-              <a:t>4社から「5つの人事システム」をスワイプする</a:t>
+              <a:t>5社から「5つの人事システム」をスワイプする</a:t>
             </a:r>
             <a:endParaRPr lang="en-US" sz="2600" dirty="0"/>
           </a:p>
@@ -4883,18 +4883,18 @@
       </p:sp>
       <p:sp>
         <p:nvSpPr>
-          <p:cNvPr id="5" name="target Google"/>
+          <p:cNvPr id="5" name="target Tesla"/>
           <p:cNvSpPr/>
           <p:nvPr/>
         </p:nvSpPr>
         <p:spPr>
           <a:xfrm>
             <a:off x="548640" y="1645920"/>
-            <a:ext cx="2011680" cy="566928"/>
+            <a:ext cx="2011680" cy="457200"/>
           </a:xfrm>
           <a:prstGeom prst="roundRect">
             <a:avLst>
-              <a:gd name="adj" fmla="val 12903"/>
+              <a:gd name="adj" fmla="val 16000"/>
             </a:avLst>
           </a:prstGeom>
           <a:solidFill>
@@ -4912,7 +4912,7 @@
         <p:spPr>
           <a:xfrm>
             <a:off x="548640" y="1645920"/>
-            <a:ext cx="2011680" cy="566928"/>
+            <a:ext cx="2011680" cy="457200"/>
           </a:xfrm>
           <a:prstGeom prst="rect">
             <a:avLst/>
@@ -4933,7 +4933,7 @@
                   <a:schemeClr val="bg1"/>
                 </a:solidFill>
               </a:rPr>
-              <a:t>Google</a:t>
+              <a:t>Tesla</a:t>
             </a:r>
             <a:endParaRPr lang="en-US" sz="1600" dirty="0"/>
           </a:p>
@@ -4941,18 +4941,18 @@
       </p:sp>
       <p:sp>
         <p:nvSpPr>
-          <p:cNvPr id="7" name="target Meta"/>
+          <p:cNvPr id="7" name="target Google"/>
           <p:cNvSpPr/>
           <p:nvPr/>
         </p:nvSpPr>
         <p:spPr>
           <a:xfrm>
-            <a:off x="548640" y="2359152"/>
-            <a:ext cx="2011680" cy="566928"/>
+            <a:off x="548640" y="2212848"/>
+            <a:ext cx="2011680" cy="457200"/>
           </a:xfrm>
           <a:prstGeom prst="roundRect">
             <a:avLst>
-              <a:gd name="adj" fmla="val 12903"/>
+              <a:gd name="adj" fmla="val 16000"/>
             </a:avLst>
           </a:prstGeom>
           <a:solidFill>
@@ -4969,8 +4969,8 @@
         </p:nvSpPr>
         <p:spPr>
           <a:xfrm>
-            <a:off x="548640" y="2359152"/>
-            <a:ext cx="2011680" cy="566928"/>
+            <a:off x="548640" y="2212848"/>
+            <a:ext cx="2011680" cy="457200"/>
           </a:xfrm>
           <a:prstGeom prst="rect">
             <a:avLst/>
@@ -4991,7 +4991,7 @@
                   <a:schemeClr val="bg1"/>
                 </a:solidFill>
               </a:rPr>
-              <a:t>Meta</a:t>
+              <a:t>Google</a:t>
             </a:r>
             <a:endParaRPr lang="en-US" sz="1600" dirty="0"/>
           </a:p>
@@ -4999,18 +4999,18 @@
       </p:sp>
       <p:sp>
         <p:nvSpPr>
-          <p:cNvPr id="9" name="target Stanford"/>
+          <p:cNvPr id="9" name="target NASA"/>
           <p:cNvSpPr/>
           <p:nvPr/>
         </p:nvSpPr>
         <p:spPr>
           <a:xfrm>
-            <a:off x="548640" y="3072384"/>
-            <a:ext cx="2011680" cy="566928"/>
+            <a:off x="548640" y="2779776"/>
+            <a:ext cx="2011680" cy="457200"/>
           </a:xfrm>
           <a:prstGeom prst="roundRect">
             <a:avLst>
-              <a:gd name="adj" fmla="val 12903"/>
+              <a:gd name="adj" fmla="val 16000"/>
             </a:avLst>
           </a:prstGeom>
           <a:solidFill>
@@ -5027,8 +5027,8 @@
         </p:nvSpPr>
         <p:spPr>
           <a:xfrm>
-            <a:off x="548640" y="3072384"/>
-            <a:ext cx="2011680" cy="566928"/>
+            <a:off x="548640" y="2779776"/>
+            <a:ext cx="2011680" cy="457200"/>
           </a:xfrm>
           <a:prstGeom prst="rect">
             <a:avLst/>
@@ -5049,7 +5049,7 @@
                   <a:schemeClr val="bg1"/>
                 </a:solidFill>
               </a:rPr>
-              <a:t>Stanford</a:t>
+              <a:t>NASA</a:t>
             </a:r>
             <a:endParaRPr lang="en-US" sz="1600" dirty="0"/>
           </a:p>
@@ -5057,18 +5057,18 @@
       </p:sp>
       <p:sp>
         <p:nvSpPr>
-          <p:cNvPr id="11" name="target Tesla"/>
+          <p:cNvPr id="11" name="target Meta"/>
           <p:cNvSpPr/>
           <p:nvPr/>
         </p:nvSpPr>
         <p:spPr>
           <a:xfrm>
-            <a:off x="548640" y="3785616"/>
-            <a:ext cx="2011680" cy="566928"/>
+            <a:off x="548640" y="3346704"/>
+            <a:ext cx="2011680" cy="457200"/>
           </a:xfrm>
           <a:prstGeom prst="roundRect">
             <a:avLst>
-              <a:gd name="adj" fmla="val 12903"/>
+              <a:gd name="adj" fmla="val 16000"/>
             </a:avLst>
           </a:prstGeom>
           <a:solidFill>
@@ -5085,8 +5085,8 @@
         </p:nvSpPr>
         <p:spPr>
           <a:xfrm>
-            <a:off x="548640" y="3785616"/>
-            <a:ext cx="2011680" cy="566928"/>
+            <a:off x="548640" y="3346704"/>
+            <a:ext cx="2011680" cy="457200"/>
           </a:xfrm>
           <a:prstGeom prst="rect">
             <a:avLst/>
@@ -5107,7 +5107,7 @@
                   <a:schemeClr val="bg1"/>
                 </a:solidFill>
               </a:rPr>
-              <a:t>Tesla</a:t>
+              <a:t>Meta</a:t>
             </a:r>
             <a:endParaRPr lang="en-US" sz="1600" dirty="0"/>
           </a:p>
@@ -5115,7 +5115,65 @@
       </p:sp>
       <p:sp>
         <p:nvSpPr>
-          <p:cNvPr id="13" name="Text 11"/>
+          <p:cNvPr id="13" name="target Stanford"/>
+          <p:cNvSpPr/>
+          <p:nvPr/>
+        </p:nvSpPr>
+        <p:spPr>
+          <a:xfrm>
+            <a:off x="548640" y="3913632"/>
+            <a:ext cx="2011680" cy="457200"/>
+          </a:xfrm>
+          <a:prstGeom prst="roundRect">
+            <a:avLst>
+              <a:gd name="adj" fmla="val 16000"/>
+            </a:avLst>
+          </a:prstGeom>
+          <a:solidFill>
+            <a:schemeClr val="tx1"/>
+          </a:solidFill>
+          <a:ln/>
+        </p:spPr>
+      </p:sp>
+      <p:sp>
+        <p:nvSpPr>
+          <p:cNvPr id="14" name="Text 12"/>
+          <p:cNvSpPr txBox="1"/>
+          <p:nvPr/>
+        </p:nvSpPr>
+        <p:spPr>
+          <a:xfrm>
+            <a:off x="548640" y="3913632"/>
+            <a:ext cx="2011680" cy="457200"/>
+          </a:xfrm>
+          <a:prstGeom prst="rect">
+            <a:avLst/>
+          </a:prstGeom>
+          <a:noFill/>
+          <a:ln/>
+        </p:spPr>
+        <p:txBody>
+          <a:bodyPr wrap="square" lIns="0" tIns="0" rIns="0" bIns="0" rtlCol="0" anchor="ctr"/>
+          <a:lstStyle/>
+          <a:p>
+            <a:pPr algn="ctr" indent="0" marL="0">
+              <a:buNone/>
+            </a:pPr>
+            <a:r>
+              <a:rPr lang="en-US" sz="1600" b="1" dirty="0">
+                <a:solidFill>
+                  <a:schemeClr val="bg1"/>
+                </a:solidFill>
+              </a:rPr>
+              <a:t>Stanford</a:t>
+            </a:r>
+            <a:endParaRPr lang="en-US" sz="1600" dirty="0"/>
+          </a:p>
+        </p:txBody>
+      </p:sp>
+      <p:sp>
+        <p:nvSpPr>
+          <p:cNvPr id="15" name="Text 13"/>
           <p:cNvSpPr txBox="1"/>
           <p:nvPr/>
         </p:nvSpPr>
@@ -5151,7 +5209,7 @@
       </p:sp>
       <p:sp>
         <p:nvSpPr>
-          <p:cNvPr id="14" name="sys 評価 circle"/>
+          <p:cNvPr id="16" name="sys 評価 circle"/>
           <p:cNvSpPr/>
           <p:nvPr/>
         </p:nvSpPr>
@@ -5171,7 +5229,7 @@
       </p:sp>
       <p:pic>
         <p:nvPicPr>
-          <p:cNvPr id="15" name="sys 評価 icon" descr="preencoded.png">    </p:cNvPr>
+          <p:cNvPr id="17" name="sys 評価 icon" descr="preencoded.png">    </p:cNvPr>
           <p:cNvPicPr>
             <a:picLocks noChangeAspect="1"/>
           </p:cNvPicPr>
@@ -5195,7 +5253,7 @@
       </p:pic>
       <p:sp>
         <p:nvSpPr>
-          <p:cNvPr id="16" name="Text 13"/>
+          <p:cNvPr id="18" name="Text 15"/>
           <p:cNvSpPr txBox="1"/>
           <p:nvPr/>
         </p:nvSpPr>
@@ -5231,7 +5289,7 @@
       </p:sp>
       <p:sp>
         <p:nvSpPr>
-          <p:cNvPr id="17" name="Text 14"/>
+          <p:cNvPr id="19" name="Text 16"/>
           <p:cNvSpPr txBox="1"/>
           <p:nvPr/>
         </p:nvSpPr>
@@ -5267,7 +5325,7 @@
       </p:sp>
       <p:sp>
         <p:nvSpPr>
-          <p:cNvPr id="18" name="sys 組織 circle"/>
+          <p:cNvPr id="20" name="sys 組織 circle"/>
           <p:cNvSpPr/>
           <p:nvPr/>
         </p:nvSpPr>
@@ -5287,7 +5345,7 @@
       </p:sp>
       <p:pic>
         <p:nvPicPr>
-          <p:cNvPr id="19" name="sys 組織 icon" descr="preencoded.png">    </p:cNvPr>
+          <p:cNvPr id="21" name="sys 組織 icon" descr="preencoded.png">    </p:cNvPr>
           <p:cNvPicPr>
             <a:picLocks noChangeAspect="1"/>
           </p:cNvPicPr>
@@ -5311,7 +5369,7 @@
       </p:pic>
       <p:sp>
         <p:nvSpPr>
-          <p:cNvPr id="20" name="Text 16"/>
+          <p:cNvPr id="22" name="Text 18"/>
           <p:cNvSpPr txBox="1"/>
           <p:nvPr/>
         </p:nvSpPr>
@@ -5347,7 +5405,7 @@
       </p:sp>
       <p:sp>
         <p:nvSpPr>
-          <p:cNvPr id="21" name="Text 17"/>
+          <p:cNvPr id="23" name="Text 19"/>
           <p:cNvSpPr txBox="1"/>
           <p:nvPr/>
         </p:nvSpPr>
@@ -5383,7 +5441,7 @@
       </p:sp>
       <p:sp>
         <p:nvSpPr>
-          <p:cNvPr id="22" name="sys 給与 circle"/>
+          <p:cNvPr id="24" name="sys 給与 circle"/>
           <p:cNvSpPr/>
           <p:nvPr/>
         </p:nvSpPr>
@@ -5403,7 +5461,7 @@
       </p:sp>
       <p:pic>
         <p:nvPicPr>
-          <p:cNvPr id="23" name="sys 給与 icon" descr="preencoded.png">    </p:cNvPr>
+          <p:cNvPr id="25" name="sys 給与 icon" descr="preencoded.png">    </p:cNvPr>
           <p:cNvPicPr>
             <a:picLocks noChangeAspect="1"/>
           </p:cNvPicPr>
@@ -5427,7 +5485,7 @@
       </p:pic>
       <p:sp>
         <p:nvSpPr>
-          <p:cNvPr id="24" name="Text 19"/>
+          <p:cNvPr id="26" name="Text 21"/>
           <p:cNvSpPr txBox="1"/>
           <p:nvPr/>
         </p:nvSpPr>
@@ -5463,7 +5521,7 @@
       </p:sp>
       <p:sp>
         <p:nvSpPr>
-          <p:cNvPr id="25" name="Text 20"/>
+          <p:cNvPr id="27" name="Text 22"/>
           <p:cNvSpPr txBox="1"/>
           <p:nvPr/>
         </p:nvSpPr>
@@ -5499,7 +5557,7 @@
       </p:sp>
       <p:sp>
         <p:nvSpPr>
-          <p:cNvPr id="26" name="sys 教育 circle"/>
+          <p:cNvPr id="28" name="sys 教育 circle"/>
           <p:cNvSpPr/>
           <p:nvPr/>
         </p:nvSpPr>
@@ -5519,7 +5577,7 @@
       </p:sp>
       <p:pic>
         <p:nvPicPr>
-          <p:cNvPr id="27" name="sys 教育 icon" descr="preencoded.png">    </p:cNvPr>
+          <p:cNvPr id="29" name="sys 教育 icon" descr="preencoded.png">    </p:cNvPr>
           <p:cNvPicPr>
             <a:picLocks noChangeAspect="1"/>
           </p:cNvPicPr>
@@ -5543,7 +5601,7 @@
       </p:pic>
       <p:sp>
         <p:nvSpPr>
-          <p:cNvPr id="28" name="Text 22"/>
+          <p:cNvPr id="30" name="Text 24"/>
           <p:cNvSpPr txBox="1"/>
           <p:nvPr/>
         </p:nvSpPr>
@@ -5579,7 +5637,7 @@
       </p:sp>
       <p:sp>
         <p:nvSpPr>
-          <p:cNvPr id="29" name="Text 23"/>
+          <p:cNvPr id="31" name="Text 25"/>
           <p:cNvSpPr txBox="1"/>
           <p:nvPr/>
         </p:nvSpPr>
@@ -5615,7 +5673,7 @@
       </p:sp>
       <p:sp>
         <p:nvSpPr>
-          <p:cNvPr id="30" name="sys 採用 circle"/>
+          <p:cNvPr id="32" name="sys 採用 circle"/>
           <p:cNvSpPr/>
           <p:nvPr/>
         </p:nvSpPr>
@@ -5635,7 +5693,7 @@
       </p:sp>
       <p:pic>
         <p:nvPicPr>
-          <p:cNvPr id="31" name="sys 採用 icon" descr="preencoded.png">    </p:cNvPr>
+          <p:cNvPr id="33" name="sys 採用 icon" descr="preencoded.png">    </p:cNvPr>
           <p:cNvPicPr>
             <a:picLocks noChangeAspect="1"/>
           </p:cNvPicPr>
@@ -5659,7 +5717,7 @@
       </p:pic>
       <p:sp>
         <p:nvSpPr>
-          <p:cNvPr id="32" name="Text 25"/>
+          <p:cNvPr id="34" name="Text 27"/>
           <p:cNvSpPr txBox="1"/>
           <p:nvPr/>
         </p:nvSpPr>
@@ -5695,7 +5753,7 @@
       </p:sp>
       <p:sp>
         <p:nvSpPr>
-          <p:cNvPr id="33" name="Text 26"/>
+          <p:cNvPr id="35" name="Text 28"/>
           <p:cNvSpPr txBox="1"/>
           <p:nvPr/>
         </p:nvSpPr>

</xml_diff>